<commit_message>
Unify Aura typography on Gabarito.
Load Gabarito from next/font on the docs site and start the shared sans stack with that family, keeping the system fallbacks.

Co-authored-by: Pablo Orozco <pablopvsky@users.noreply.github.com>
</commit_message>
<xml_diff>
--- a/apps/www/public/fixtures/sample.pptx
+++ b/apps/www/public/fixtures/sample.pptx
@@ -1411,9 +1411,9 @@
                 <a:solidFill>
                   <a:srgbClr val="FCFAFF"/>
                 </a:solidFill>
-                <a:latin typeface="Inter" pitchFamily="34" charset="0"/>
-                <a:ea typeface="Inter" pitchFamily="34" charset="-122"/>
-                <a:cs typeface="Inter" pitchFamily="34" charset="-120"/>
+                <a:latin typeface="Gabarito" pitchFamily="34" charset="0"/>
+                <a:ea typeface="Gabarito" pitchFamily="34" charset="-122"/>
+                <a:cs typeface="Gabarito" pitchFamily="34" charset="-120"/>
               </a:rPr>
               <a:t>Design tokens</a:t>
             </a:r>
@@ -1431,9 +1431,9 @@
                 <a:solidFill>
                   <a:srgbClr val="FCFAFF"/>
                 </a:solidFill>
-                <a:latin typeface="Inter" pitchFamily="34" charset="0"/>
-                <a:ea typeface="Inter" pitchFamily="34" charset="-122"/>
-                <a:cs typeface="Inter" pitchFamily="34" charset="-120"/>
+                <a:latin typeface="Gabarito" pitchFamily="34" charset="0"/>
+                <a:ea typeface="Gabarito" pitchFamily="34" charset="-122"/>
+                <a:cs typeface="Gabarito" pitchFamily="34" charset="-120"/>
               </a:rPr>
               <a:t>you can install.</a:t>
             </a:r>
@@ -1493,9 +1493,9 @@
                 <a:solidFill>
                   <a:srgbClr val="D9D1FF"/>
                 </a:solidFill>
-                <a:latin typeface="Inter" pitchFamily="34" charset="0"/>
-                <a:ea typeface="Inter" pitchFamily="34" charset="-122"/>
-                <a:cs typeface="Inter" pitchFamily="34" charset="-120"/>
+                <a:latin typeface="Gabarito" pitchFamily="34" charset="0"/>
+                <a:ea typeface="Gabarito" pitchFamily="34" charset="-122"/>
+                <a:cs typeface="Gabarito" pitchFamily="34" charset="-120"/>
               </a:rPr>
               <a:t>A 12-step accent and gray palette, fluid typography, and a 13px spacing grid — shipped as a shadcn registry.</a:t>
             </a:r>
@@ -1662,9 +1662,9 @@
                 <a:solidFill>
                   <a:srgbClr val="27005F"/>
                 </a:solidFill>
-                <a:latin typeface="Inter" pitchFamily="34" charset="0"/>
-                <a:ea typeface="Inter" pitchFamily="34" charset="-122"/>
-                <a:cs typeface="Inter" pitchFamily="34" charset="-120"/>
+                <a:latin typeface="Gabarito" pitchFamily="34" charset="0"/>
+                <a:ea typeface="Gabarito" pitchFamily="34" charset="-122"/>
+                <a:cs typeface="Gabarito" pitchFamily="34" charset="-120"/>
               </a:rPr>
               <a:t>Twelve steps, one intent per step.</a:t>
             </a:r>
@@ -2508,9 +2508,9 @@
                 <a:solidFill>
                   <a:srgbClr val="6949BF"/>
                 </a:solidFill>
-                <a:latin typeface="Inter" pitchFamily="34" charset="0"/>
-                <a:ea typeface="Inter" pitchFamily="34" charset="-122"/>
-                <a:cs typeface="Inter" pitchFamily="34" charset="-120"/>
+                <a:latin typeface="Gabarito" pitchFamily="34" charset="0"/>
+                <a:ea typeface="Gabarito" pitchFamily="34" charset="-122"/>
+                <a:cs typeface="Gabarito" pitchFamily="34" charset="-120"/>
               </a:rPr>
               <a:t>App and card backgrounds</a:t>
             </a:r>
@@ -2586,9 +2586,9 @@
                 <a:solidFill>
                   <a:srgbClr val="6949BF"/>
                 </a:solidFill>
-                <a:latin typeface="Inter" pitchFamily="34" charset="0"/>
-                <a:ea typeface="Inter" pitchFamily="34" charset="-122"/>
-                <a:cs typeface="Inter" pitchFamily="34" charset="-120"/>
+                <a:latin typeface="Gabarito" pitchFamily="34" charset="0"/>
+                <a:ea typeface="Gabarito" pitchFamily="34" charset="-122"/>
+                <a:cs typeface="Gabarito" pitchFamily="34" charset="-120"/>
               </a:rPr>
               <a:t>Component fill: rest, hover, active</a:t>
             </a:r>
@@ -2664,9 +2664,9 @@
                 <a:solidFill>
                   <a:srgbClr val="6949BF"/>
                 </a:solidFill>
-                <a:latin typeface="Inter" pitchFamily="34" charset="0"/>
-                <a:ea typeface="Inter" pitchFamily="34" charset="-122"/>
-                <a:cs typeface="Inter" pitchFamily="34" charset="-120"/>
+                <a:latin typeface="Gabarito" pitchFamily="34" charset="0"/>
+                <a:ea typeface="Gabarito" pitchFamily="34" charset="-122"/>
+                <a:cs typeface="Gabarito" pitchFamily="34" charset="-120"/>
               </a:rPr>
               <a:t>Borders, then focus rings</a:t>
             </a:r>
@@ -2742,9 +2742,9 @@
                 <a:solidFill>
                   <a:srgbClr val="6949BF"/>
                 </a:solidFill>
-                <a:latin typeface="Inter" pitchFamily="34" charset="0"/>
-                <a:ea typeface="Inter" pitchFamily="34" charset="-122"/>
-                <a:cs typeface="Inter" pitchFamily="34" charset="-120"/>
+                <a:latin typeface="Gabarito" pitchFamily="34" charset="0"/>
+                <a:ea typeface="Gabarito" pitchFamily="34" charset="-122"/>
+                <a:cs typeface="Gabarito" pitchFamily="34" charset="-120"/>
               </a:rPr>
               <a:t>Solid brand fills</a:t>
             </a:r>
@@ -2820,9 +2820,9 @@
                 <a:solidFill>
                   <a:srgbClr val="6949BF"/>
                 </a:solidFill>
-                <a:latin typeface="Inter" pitchFamily="34" charset="0"/>
-                <a:ea typeface="Inter" pitchFamily="34" charset="-122"/>
-                <a:cs typeface="Inter" pitchFamily="34" charset="-120"/>
+                <a:latin typeface="Gabarito" pitchFamily="34" charset="0"/>
+                <a:ea typeface="Gabarito" pitchFamily="34" charset="-122"/>
+                <a:cs typeface="Gabarito" pitchFamily="34" charset="-120"/>
               </a:rPr>
               <a:t>Low- and high-contrast text</a:t>
             </a:r>
@@ -2950,9 +2950,9 @@
                 <a:solidFill>
                   <a:srgbClr val="27005F"/>
                 </a:solidFill>
-                <a:latin typeface="Inter" pitchFamily="34" charset="0"/>
-                <a:ea typeface="Inter" pitchFamily="34" charset="-122"/>
-                <a:cs typeface="Inter" pitchFamily="34" charset="-120"/>
+                <a:latin typeface="Gabarito" pitchFamily="34" charset="0"/>
+                <a:ea typeface="Gabarito" pitchFamily="34" charset="-122"/>
+                <a:cs typeface="Gabarito" pitchFamily="34" charset="-120"/>
               </a:rPr>
               <a:t>Type scales with the viewport.</a:t>
             </a:r>
@@ -3067,9 +3067,9 @@
                 <a:solidFill>
                   <a:srgbClr val="27005F"/>
                 </a:solidFill>
-                <a:latin typeface="Inter" pitchFamily="34" charset="0"/>
-                <a:ea typeface="Inter" pitchFamily="34" charset="-122"/>
-                <a:cs typeface="Inter" pitchFamily="34" charset="-120"/>
+                <a:latin typeface="Gabarito" pitchFamily="34" charset="0"/>
+                <a:ea typeface="Gabarito" pitchFamily="34" charset="-122"/>
+                <a:cs typeface="Gabarito" pitchFamily="34" charset="-120"/>
               </a:rPr>
               <a:t>Aa — 1.98 to 3.05rem</a:t>
             </a:r>
@@ -3145,9 +3145,9 @@
                 <a:solidFill>
                   <a:srgbClr val="27005F"/>
                 </a:solidFill>
-                <a:latin typeface="Inter" pitchFamily="34" charset="0"/>
-                <a:ea typeface="Inter" pitchFamily="34" charset="-122"/>
-                <a:cs typeface="Inter" pitchFamily="34" charset="-120"/>
+                <a:latin typeface="Gabarito" pitchFamily="34" charset="0"/>
+                <a:ea typeface="Gabarito" pitchFamily="34" charset="-122"/>
+                <a:cs typeface="Gabarito" pitchFamily="34" charset="-120"/>
               </a:rPr>
               <a:t>Aa — 1.59 to 2.44rem</a:t>
             </a:r>
@@ -3223,9 +3223,9 @@
                 <a:solidFill>
                   <a:srgbClr val="27005F"/>
                 </a:solidFill>
-                <a:latin typeface="Inter" pitchFamily="34" charset="0"/>
-                <a:ea typeface="Inter" pitchFamily="34" charset="-122"/>
-                <a:cs typeface="Inter" pitchFamily="34" charset="-120"/>
+                <a:latin typeface="Gabarito" pitchFamily="34" charset="0"/>
+                <a:ea typeface="Gabarito" pitchFamily="34" charset="-122"/>
+                <a:cs typeface="Gabarito" pitchFamily="34" charset="-120"/>
               </a:rPr>
               <a:t>Aa — 1.48 to 2.28rem</a:t>
             </a:r>
@@ -3301,9 +3301,9 @@
                 <a:solidFill>
                   <a:srgbClr val="6949BF"/>
                 </a:solidFill>
-                <a:latin typeface="Inter" pitchFamily="34" charset="0"/>
-                <a:ea typeface="Inter" pitchFamily="34" charset="-122"/>
-                <a:cs typeface="Inter" pitchFamily="34" charset="-120"/>
+                <a:latin typeface="Gabarito" pitchFamily="34" charset="0"/>
+                <a:ea typeface="Gabarito" pitchFamily="34" charset="-122"/>
+                <a:cs typeface="Gabarito" pitchFamily="34" charset="-120"/>
               </a:rPr>
               <a:t>Aa — 1rem body copy</a:t>
             </a:r>
@@ -3431,9 +3431,9 @@
                 <a:solidFill>
                   <a:srgbClr val="27005F"/>
                 </a:solidFill>
-                <a:latin typeface="Inter" pitchFamily="34" charset="0"/>
-                <a:ea typeface="Inter" pitchFamily="34" charset="-122"/>
-                <a:cs typeface="Inter" pitchFamily="34" charset="-120"/>
+                <a:latin typeface="Gabarito" pitchFamily="34" charset="0"/>
+                <a:ea typeface="Gabarito" pitchFamily="34" charset="-122"/>
+                <a:cs typeface="Gabarito" pitchFamily="34" charset="-120"/>
               </a:rPr>
               <a:t>Everything lands on 13px.</a:t>
             </a:r>
@@ -3470,9 +3470,9 @@
                 <a:solidFill>
                   <a:srgbClr val="6949BF"/>
                 </a:solidFill>
-                <a:latin typeface="Inter" pitchFamily="34" charset="0"/>
-                <a:ea typeface="Inter" pitchFamily="34" charset="-122"/>
-                <a:cs typeface="Inter" pitchFamily="34" charset="-120"/>
+                <a:latin typeface="Gabarito" pitchFamily="34" charset="0"/>
+                <a:ea typeface="Gabarito" pitchFamily="34" charset="-122"/>
+                <a:cs typeface="Gabarito" pitchFamily="34" charset="-120"/>
               </a:rPr>
               <a:t>Tailwind utilities inherit --spacing: 13px, so p-4 is 52px — not 16px.</a:t>
             </a:r>
@@ -3992,9 +3992,9 @@
                 <a:solidFill>
                   <a:srgbClr val="27005F"/>
                 </a:solidFill>
-                <a:latin typeface="Inter" pitchFamily="34" charset="0"/>
-                <a:ea typeface="Inter" pitchFamily="34" charset="-122"/>
-                <a:cs typeface="Inter" pitchFamily="34" charset="-120"/>
+                <a:latin typeface="Gabarito" pitchFamily="34" charset="0"/>
+                <a:ea typeface="Gabarito" pitchFamily="34" charset="-122"/>
+                <a:cs typeface="Gabarito" pitchFamily="34" charset="-120"/>
               </a:rPr>
               <a:t>Stack sheets before drawing lines.</a:t>
             </a:r>
@@ -4097,9 +4097,9 @@
                 <a:solidFill>
                   <a:srgbClr val="27005F"/>
                 </a:solidFill>
-                <a:latin typeface="Inter" pitchFamily="34" charset="0"/>
-                <a:ea typeface="Inter" pitchFamily="34" charset="-122"/>
-                <a:cs typeface="Inter" pitchFamily="34" charset="-120"/>
+                <a:latin typeface="Gabarito" pitchFamily="34" charset="0"/>
+                <a:ea typeface="Gabarito" pitchFamily="34" charset="-122"/>
+                <a:cs typeface="Gabarito" pitchFamily="34" charset="-120"/>
               </a:rPr>
               <a:t>Canvas</a:t>
             </a:r>
@@ -4202,9 +4202,9 @@
                 <a:solidFill>
                   <a:srgbClr val="27005F"/>
                 </a:solidFill>
-                <a:latin typeface="Inter" pitchFamily="34" charset="0"/>
-                <a:ea typeface="Inter" pitchFamily="34" charset="-122"/>
-                <a:cs typeface="Inter" pitchFamily="34" charset="-120"/>
+                <a:latin typeface="Gabarito" pitchFamily="34" charset="0"/>
+                <a:ea typeface="Gabarito" pitchFamily="34" charset="-122"/>
+                <a:cs typeface="Gabarito" pitchFamily="34" charset="-120"/>
               </a:rPr>
               <a:t>Card surface</a:t>
             </a:r>
@@ -4307,9 +4307,9 @@
                 <a:solidFill>
                   <a:srgbClr val="27005F"/>
                 </a:solidFill>
-                <a:latin typeface="Inter" pitchFamily="34" charset="0"/>
-                <a:ea typeface="Inter" pitchFamily="34" charset="-122"/>
-                <a:cs typeface="Inter" pitchFamily="34" charset="-120"/>
+                <a:latin typeface="Gabarito" pitchFamily="34" charset="0"/>
+                <a:ea typeface="Gabarito" pitchFamily="34" charset="-122"/>
+                <a:cs typeface="Gabarito" pitchFamily="34" charset="-120"/>
               </a:rPr>
               <a:t>Lifted / hover</a:t>
             </a:r>
@@ -4412,9 +4412,9 @@
                 <a:solidFill>
                   <a:srgbClr val="FFFFFF"/>
                 </a:solidFill>
-                <a:latin typeface="Inter" pitchFamily="34" charset="0"/>
-                <a:ea typeface="Inter" pitchFamily="34" charset="-122"/>
-                <a:cs typeface="Inter" pitchFamily="34" charset="-120"/>
+                <a:latin typeface="Gabarito" pitchFamily="34" charset="0"/>
+                <a:ea typeface="Gabarito" pitchFamily="34" charset="-122"/>
+                <a:cs typeface="Gabarito" pitchFamily="34" charset="-120"/>
               </a:rPr>
               <a:t>Primary action</a:t>
             </a:r>
@@ -4451,9 +4451,9 @@
                 <a:solidFill>
                   <a:srgbClr val="6949BF"/>
                 </a:solidFill>
-                <a:latin typeface="Inter" pitchFamily="34" charset="0"/>
-                <a:ea typeface="Inter" pitchFamily="34" charset="-122"/>
-                <a:cs typeface="Inter" pitchFamily="34" charset="-120"/>
+                <a:latin typeface="Gabarito" pitchFamily="34" charset="0"/>
+                <a:ea typeface="Gabarito" pitchFamily="34" charset="-122"/>
+                <a:cs typeface="Gabarito" pitchFamily="34" charset="-120"/>
               </a:rPr>
               <a:t>Borders at steps 6–8 only where structure has to read: dialogs, menus, and controls.</a:t>
             </a:r>
@@ -4545,9 +4545,9 @@
                 <a:solidFill>
                   <a:srgbClr val="FFFFFF"/>
                 </a:solidFill>
-                <a:latin typeface="Inter" pitchFamily="34" charset="0"/>
-                <a:ea typeface="Inter" pitchFamily="34" charset="-122"/>
-                <a:cs typeface="Inter" pitchFamily="34" charset="-120"/>
+                <a:latin typeface="Gabarito" pitchFamily="34" charset="0"/>
+                <a:ea typeface="Gabarito" pitchFamily="34" charset="-122"/>
+                <a:cs typeface="Gabarito" pitchFamily="34" charset="-120"/>
               </a:rPr>
               <a:t>Install the system,</a:t>
             </a:r>
@@ -4565,9 +4565,9 @@
                 <a:solidFill>
                   <a:srgbClr val="FFFFFF"/>
                 </a:solidFill>
-                <a:latin typeface="Inter" pitchFamily="34" charset="0"/>
-                <a:ea typeface="Inter" pitchFamily="34" charset="-122"/>
-                <a:cs typeface="Inter" pitchFamily="34" charset="-120"/>
+                <a:latin typeface="Gabarito" pitchFamily="34" charset="0"/>
+                <a:ea typeface="Gabarito" pitchFamily="34" charset="-122"/>
+                <a:cs typeface="Gabarito" pitchFamily="34" charset="-120"/>
               </a:rPr>
               <a:t>not the screenshots.</a:t>
             </a:r>

</xml_diff>

<commit_message>
Unify Aura typography on Gabarito. (#142)
Load Gabarito from next/font on the docs site and start the shared sans stack with that family, keeping the system fallbacks.

Co-authored-by: Cursor Agent <cursoragent@cursor.com>
Co-authored-by: Pablo Orozco <pablopvsky@users.noreply.github.com>
</commit_message>
<xml_diff>
--- a/apps/www/public/fixtures/sample.pptx
+++ b/apps/www/public/fixtures/sample.pptx
@@ -1411,9 +1411,9 @@
                 <a:solidFill>
                   <a:srgbClr val="FCFAFF"/>
                 </a:solidFill>
-                <a:latin typeface="Inter" pitchFamily="34" charset="0"/>
-                <a:ea typeface="Inter" pitchFamily="34" charset="-122"/>
-                <a:cs typeface="Inter" pitchFamily="34" charset="-120"/>
+                <a:latin typeface="Gabarito" pitchFamily="34" charset="0"/>
+                <a:ea typeface="Gabarito" pitchFamily="34" charset="-122"/>
+                <a:cs typeface="Gabarito" pitchFamily="34" charset="-120"/>
               </a:rPr>
               <a:t>Design tokens</a:t>
             </a:r>
@@ -1431,9 +1431,9 @@
                 <a:solidFill>
                   <a:srgbClr val="FCFAFF"/>
                 </a:solidFill>
-                <a:latin typeface="Inter" pitchFamily="34" charset="0"/>
-                <a:ea typeface="Inter" pitchFamily="34" charset="-122"/>
-                <a:cs typeface="Inter" pitchFamily="34" charset="-120"/>
+                <a:latin typeface="Gabarito" pitchFamily="34" charset="0"/>
+                <a:ea typeface="Gabarito" pitchFamily="34" charset="-122"/>
+                <a:cs typeface="Gabarito" pitchFamily="34" charset="-120"/>
               </a:rPr>
               <a:t>you can install.</a:t>
             </a:r>
@@ -1493,9 +1493,9 @@
                 <a:solidFill>
                   <a:srgbClr val="D9D1FF"/>
                 </a:solidFill>
-                <a:latin typeface="Inter" pitchFamily="34" charset="0"/>
-                <a:ea typeface="Inter" pitchFamily="34" charset="-122"/>
-                <a:cs typeface="Inter" pitchFamily="34" charset="-120"/>
+                <a:latin typeface="Gabarito" pitchFamily="34" charset="0"/>
+                <a:ea typeface="Gabarito" pitchFamily="34" charset="-122"/>
+                <a:cs typeface="Gabarito" pitchFamily="34" charset="-120"/>
               </a:rPr>
               <a:t>A 12-step accent and gray palette, fluid typography, and a 13px spacing grid — shipped as a shadcn registry.</a:t>
             </a:r>
@@ -1662,9 +1662,9 @@
                 <a:solidFill>
                   <a:srgbClr val="27005F"/>
                 </a:solidFill>
-                <a:latin typeface="Inter" pitchFamily="34" charset="0"/>
-                <a:ea typeface="Inter" pitchFamily="34" charset="-122"/>
-                <a:cs typeface="Inter" pitchFamily="34" charset="-120"/>
+                <a:latin typeface="Gabarito" pitchFamily="34" charset="0"/>
+                <a:ea typeface="Gabarito" pitchFamily="34" charset="-122"/>
+                <a:cs typeface="Gabarito" pitchFamily="34" charset="-120"/>
               </a:rPr>
               <a:t>Twelve steps, one intent per step.</a:t>
             </a:r>
@@ -2508,9 +2508,9 @@
                 <a:solidFill>
                   <a:srgbClr val="6949BF"/>
                 </a:solidFill>
-                <a:latin typeface="Inter" pitchFamily="34" charset="0"/>
-                <a:ea typeface="Inter" pitchFamily="34" charset="-122"/>
-                <a:cs typeface="Inter" pitchFamily="34" charset="-120"/>
+                <a:latin typeface="Gabarito" pitchFamily="34" charset="0"/>
+                <a:ea typeface="Gabarito" pitchFamily="34" charset="-122"/>
+                <a:cs typeface="Gabarito" pitchFamily="34" charset="-120"/>
               </a:rPr>
               <a:t>App and card backgrounds</a:t>
             </a:r>
@@ -2586,9 +2586,9 @@
                 <a:solidFill>
                   <a:srgbClr val="6949BF"/>
                 </a:solidFill>
-                <a:latin typeface="Inter" pitchFamily="34" charset="0"/>
-                <a:ea typeface="Inter" pitchFamily="34" charset="-122"/>
-                <a:cs typeface="Inter" pitchFamily="34" charset="-120"/>
+                <a:latin typeface="Gabarito" pitchFamily="34" charset="0"/>
+                <a:ea typeface="Gabarito" pitchFamily="34" charset="-122"/>
+                <a:cs typeface="Gabarito" pitchFamily="34" charset="-120"/>
               </a:rPr>
               <a:t>Component fill: rest, hover, active</a:t>
             </a:r>
@@ -2664,9 +2664,9 @@
                 <a:solidFill>
                   <a:srgbClr val="6949BF"/>
                 </a:solidFill>
-                <a:latin typeface="Inter" pitchFamily="34" charset="0"/>
-                <a:ea typeface="Inter" pitchFamily="34" charset="-122"/>
-                <a:cs typeface="Inter" pitchFamily="34" charset="-120"/>
+                <a:latin typeface="Gabarito" pitchFamily="34" charset="0"/>
+                <a:ea typeface="Gabarito" pitchFamily="34" charset="-122"/>
+                <a:cs typeface="Gabarito" pitchFamily="34" charset="-120"/>
               </a:rPr>
               <a:t>Borders, then focus rings</a:t>
             </a:r>
@@ -2742,9 +2742,9 @@
                 <a:solidFill>
                   <a:srgbClr val="6949BF"/>
                 </a:solidFill>
-                <a:latin typeface="Inter" pitchFamily="34" charset="0"/>
-                <a:ea typeface="Inter" pitchFamily="34" charset="-122"/>
-                <a:cs typeface="Inter" pitchFamily="34" charset="-120"/>
+                <a:latin typeface="Gabarito" pitchFamily="34" charset="0"/>
+                <a:ea typeface="Gabarito" pitchFamily="34" charset="-122"/>
+                <a:cs typeface="Gabarito" pitchFamily="34" charset="-120"/>
               </a:rPr>
               <a:t>Solid brand fills</a:t>
             </a:r>
@@ -2820,9 +2820,9 @@
                 <a:solidFill>
                   <a:srgbClr val="6949BF"/>
                 </a:solidFill>
-                <a:latin typeface="Inter" pitchFamily="34" charset="0"/>
-                <a:ea typeface="Inter" pitchFamily="34" charset="-122"/>
-                <a:cs typeface="Inter" pitchFamily="34" charset="-120"/>
+                <a:latin typeface="Gabarito" pitchFamily="34" charset="0"/>
+                <a:ea typeface="Gabarito" pitchFamily="34" charset="-122"/>
+                <a:cs typeface="Gabarito" pitchFamily="34" charset="-120"/>
               </a:rPr>
               <a:t>Low- and high-contrast text</a:t>
             </a:r>
@@ -2950,9 +2950,9 @@
                 <a:solidFill>
                   <a:srgbClr val="27005F"/>
                 </a:solidFill>
-                <a:latin typeface="Inter" pitchFamily="34" charset="0"/>
-                <a:ea typeface="Inter" pitchFamily="34" charset="-122"/>
-                <a:cs typeface="Inter" pitchFamily="34" charset="-120"/>
+                <a:latin typeface="Gabarito" pitchFamily="34" charset="0"/>
+                <a:ea typeface="Gabarito" pitchFamily="34" charset="-122"/>
+                <a:cs typeface="Gabarito" pitchFamily="34" charset="-120"/>
               </a:rPr>
               <a:t>Type scales with the viewport.</a:t>
             </a:r>
@@ -3067,9 +3067,9 @@
                 <a:solidFill>
                   <a:srgbClr val="27005F"/>
                 </a:solidFill>
-                <a:latin typeface="Inter" pitchFamily="34" charset="0"/>
-                <a:ea typeface="Inter" pitchFamily="34" charset="-122"/>
-                <a:cs typeface="Inter" pitchFamily="34" charset="-120"/>
+                <a:latin typeface="Gabarito" pitchFamily="34" charset="0"/>
+                <a:ea typeface="Gabarito" pitchFamily="34" charset="-122"/>
+                <a:cs typeface="Gabarito" pitchFamily="34" charset="-120"/>
               </a:rPr>
               <a:t>Aa — 1.98 to 3.05rem</a:t>
             </a:r>
@@ -3145,9 +3145,9 @@
                 <a:solidFill>
                   <a:srgbClr val="27005F"/>
                 </a:solidFill>
-                <a:latin typeface="Inter" pitchFamily="34" charset="0"/>
-                <a:ea typeface="Inter" pitchFamily="34" charset="-122"/>
-                <a:cs typeface="Inter" pitchFamily="34" charset="-120"/>
+                <a:latin typeface="Gabarito" pitchFamily="34" charset="0"/>
+                <a:ea typeface="Gabarito" pitchFamily="34" charset="-122"/>
+                <a:cs typeface="Gabarito" pitchFamily="34" charset="-120"/>
               </a:rPr>
               <a:t>Aa — 1.59 to 2.44rem</a:t>
             </a:r>
@@ -3223,9 +3223,9 @@
                 <a:solidFill>
                   <a:srgbClr val="27005F"/>
                 </a:solidFill>
-                <a:latin typeface="Inter" pitchFamily="34" charset="0"/>
-                <a:ea typeface="Inter" pitchFamily="34" charset="-122"/>
-                <a:cs typeface="Inter" pitchFamily="34" charset="-120"/>
+                <a:latin typeface="Gabarito" pitchFamily="34" charset="0"/>
+                <a:ea typeface="Gabarito" pitchFamily="34" charset="-122"/>
+                <a:cs typeface="Gabarito" pitchFamily="34" charset="-120"/>
               </a:rPr>
               <a:t>Aa — 1.48 to 2.28rem</a:t>
             </a:r>
@@ -3301,9 +3301,9 @@
                 <a:solidFill>
                   <a:srgbClr val="6949BF"/>
                 </a:solidFill>
-                <a:latin typeface="Inter" pitchFamily="34" charset="0"/>
-                <a:ea typeface="Inter" pitchFamily="34" charset="-122"/>
-                <a:cs typeface="Inter" pitchFamily="34" charset="-120"/>
+                <a:latin typeface="Gabarito" pitchFamily="34" charset="0"/>
+                <a:ea typeface="Gabarito" pitchFamily="34" charset="-122"/>
+                <a:cs typeface="Gabarito" pitchFamily="34" charset="-120"/>
               </a:rPr>
               <a:t>Aa — 1rem body copy</a:t>
             </a:r>
@@ -3431,9 +3431,9 @@
                 <a:solidFill>
                   <a:srgbClr val="27005F"/>
                 </a:solidFill>
-                <a:latin typeface="Inter" pitchFamily="34" charset="0"/>
-                <a:ea typeface="Inter" pitchFamily="34" charset="-122"/>
-                <a:cs typeface="Inter" pitchFamily="34" charset="-120"/>
+                <a:latin typeface="Gabarito" pitchFamily="34" charset="0"/>
+                <a:ea typeface="Gabarito" pitchFamily="34" charset="-122"/>
+                <a:cs typeface="Gabarito" pitchFamily="34" charset="-120"/>
               </a:rPr>
               <a:t>Everything lands on 13px.</a:t>
             </a:r>
@@ -3470,9 +3470,9 @@
                 <a:solidFill>
                   <a:srgbClr val="6949BF"/>
                 </a:solidFill>
-                <a:latin typeface="Inter" pitchFamily="34" charset="0"/>
-                <a:ea typeface="Inter" pitchFamily="34" charset="-122"/>
-                <a:cs typeface="Inter" pitchFamily="34" charset="-120"/>
+                <a:latin typeface="Gabarito" pitchFamily="34" charset="0"/>
+                <a:ea typeface="Gabarito" pitchFamily="34" charset="-122"/>
+                <a:cs typeface="Gabarito" pitchFamily="34" charset="-120"/>
               </a:rPr>
               <a:t>Tailwind utilities inherit --spacing: 13px, so p-4 is 52px — not 16px.</a:t>
             </a:r>
@@ -3992,9 +3992,9 @@
                 <a:solidFill>
                   <a:srgbClr val="27005F"/>
                 </a:solidFill>
-                <a:latin typeface="Inter" pitchFamily="34" charset="0"/>
-                <a:ea typeface="Inter" pitchFamily="34" charset="-122"/>
-                <a:cs typeface="Inter" pitchFamily="34" charset="-120"/>
+                <a:latin typeface="Gabarito" pitchFamily="34" charset="0"/>
+                <a:ea typeface="Gabarito" pitchFamily="34" charset="-122"/>
+                <a:cs typeface="Gabarito" pitchFamily="34" charset="-120"/>
               </a:rPr>
               <a:t>Stack sheets before drawing lines.</a:t>
             </a:r>
@@ -4097,9 +4097,9 @@
                 <a:solidFill>
                   <a:srgbClr val="27005F"/>
                 </a:solidFill>
-                <a:latin typeface="Inter" pitchFamily="34" charset="0"/>
-                <a:ea typeface="Inter" pitchFamily="34" charset="-122"/>
-                <a:cs typeface="Inter" pitchFamily="34" charset="-120"/>
+                <a:latin typeface="Gabarito" pitchFamily="34" charset="0"/>
+                <a:ea typeface="Gabarito" pitchFamily="34" charset="-122"/>
+                <a:cs typeface="Gabarito" pitchFamily="34" charset="-120"/>
               </a:rPr>
               <a:t>Canvas</a:t>
             </a:r>
@@ -4202,9 +4202,9 @@
                 <a:solidFill>
                   <a:srgbClr val="27005F"/>
                 </a:solidFill>
-                <a:latin typeface="Inter" pitchFamily="34" charset="0"/>
-                <a:ea typeface="Inter" pitchFamily="34" charset="-122"/>
-                <a:cs typeface="Inter" pitchFamily="34" charset="-120"/>
+                <a:latin typeface="Gabarito" pitchFamily="34" charset="0"/>
+                <a:ea typeface="Gabarito" pitchFamily="34" charset="-122"/>
+                <a:cs typeface="Gabarito" pitchFamily="34" charset="-120"/>
               </a:rPr>
               <a:t>Card surface</a:t>
             </a:r>
@@ -4307,9 +4307,9 @@
                 <a:solidFill>
                   <a:srgbClr val="27005F"/>
                 </a:solidFill>
-                <a:latin typeface="Inter" pitchFamily="34" charset="0"/>
-                <a:ea typeface="Inter" pitchFamily="34" charset="-122"/>
-                <a:cs typeface="Inter" pitchFamily="34" charset="-120"/>
+                <a:latin typeface="Gabarito" pitchFamily="34" charset="0"/>
+                <a:ea typeface="Gabarito" pitchFamily="34" charset="-122"/>
+                <a:cs typeface="Gabarito" pitchFamily="34" charset="-120"/>
               </a:rPr>
               <a:t>Lifted / hover</a:t>
             </a:r>
@@ -4412,9 +4412,9 @@
                 <a:solidFill>
                   <a:srgbClr val="FFFFFF"/>
                 </a:solidFill>
-                <a:latin typeface="Inter" pitchFamily="34" charset="0"/>
-                <a:ea typeface="Inter" pitchFamily="34" charset="-122"/>
-                <a:cs typeface="Inter" pitchFamily="34" charset="-120"/>
+                <a:latin typeface="Gabarito" pitchFamily="34" charset="0"/>
+                <a:ea typeface="Gabarito" pitchFamily="34" charset="-122"/>
+                <a:cs typeface="Gabarito" pitchFamily="34" charset="-120"/>
               </a:rPr>
               <a:t>Primary action</a:t>
             </a:r>
@@ -4451,9 +4451,9 @@
                 <a:solidFill>
                   <a:srgbClr val="6949BF"/>
                 </a:solidFill>
-                <a:latin typeface="Inter" pitchFamily="34" charset="0"/>
-                <a:ea typeface="Inter" pitchFamily="34" charset="-122"/>
-                <a:cs typeface="Inter" pitchFamily="34" charset="-120"/>
+                <a:latin typeface="Gabarito" pitchFamily="34" charset="0"/>
+                <a:ea typeface="Gabarito" pitchFamily="34" charset="-122"/>
+                <a:cs typeface="Gabarito" pitchFamily="34" charset="-120"/>
               </a:rPr>
               <a:t>Borders at steps 6–8 only where structure has to read: dialogs, menus, and controls.</a:t>
             </a:r>
@@ -4545,9 +4545,9 @@
                 <a:solidFill>
                   <a:srgbClr val="FFFFFF"/>
                 </a:solidFill>
-                <a:latin typeface="Inter" pitchFamily="34" charset="0"/>
-                <a:ea typeface="Inter" pitchFamily="34" charset="-122"/>
-                <a:cs typeface="Inter" pitchFamily="34" charset="-120"/>
+                <a:latin typeface="Gabarito" pitchFamily="34" charset="0"/>
+                <a:ea typeface="Gabarito" pitchFamily="34" charset="-122"/>
+                <a:cs typeface="Gabarito" pitchFamily="34" charset="-120"/>
               </a:rPr>
               <a:t>Install the system,</a:t>
             </a:r>
@@ -4565,9 +4565,9 @@
                 <a:solidFill>
                   <a:srgbClr val="FFFFFF"/>
                 </a:solidFill>
-                <a:latin typeface="Inter" pitchFamily="34" charset="0"/>
-                <a:ea typeface="Inter" pitchFamily="34" charset="-122"/>
-                <a:cs typeface="Inter" pitchFamily="34" charset="-120"/>
+                <a:latin typeface="Gabarito" pitchFamily="34" charset="0"/>
+                <a:ea typeface="Gabarito" pitchFamily="34" charset="-122"/>
+                <a:cs typeface="Gabarito" pitchFamily="34" charset="-120"/>
               </a:rPr>
               <a:t>not the screenshots.</a:t>
             </a:r>

</xml_diff>